<commit_message>
creative-experiments: black-box gallery merged into original, redesign repo deleted, decks updated
</commit_message>
<xml_diff>
--- a/decks/creative-experiments-redesign.pptx
+++ b/decks/creative-experiments-redesign.pptx
@@ -3106,8 +3106,8 @@
         </p:blipFill>
         <p:spPr>
           <a:xfrm>
-            <a:off x="1219047" y="0"/>
-            <a:ext cx="9753600" cy="6858000"/>
+            <a:off x="1934311" y="137160"/>
+            <a:ext cx="8323072" cy="5852160"/>
           </a:xfrm>
           <a:prstGeom prst="rect">
             <a:avLst/>
@@ -3122,8 +3122,8 @@
         </p:nvSpPr>
         <p:spPr>
           <a:xfrm>
-            <a:off x="274320" y="6217920"/>
-            <a:ext cx="10972800" cy="457200"/>
+            <a:off x="365760" y="5989320"/>
+            <a:ext cx="11430000" cy="777240"/>
           </a:xfrm>
           <a:prstGeom prst="rect">
             <a:avLst/>
@@ -3131,13 +3131,13 @@
           <a:noFill/>
         </p:spPr>
         <p:txBody>
-          <a:bodyPr wrap="none">
+          <a:bodyPr wrap="square">
             <a:spAutoFit/>
           </a:bodyPr>
           <a:lstStyle/>
           <a:p>
             <a:pPr>
-              <a:defRPr sz="1400">
+              <a:defRPr sz="1500">
                 <a:solidFill>
                   <a:srgbClr val="888888"/>
                 </a:solidFill>
@@ -3145,7 +3145,7 @@
               </a:defRPr>
             </a:pPr>
             <a:r>
-              <a:t>Before — 22% slop</a:t>
+              <a:t>Creative Experiments — before · 22% slop</a:t>
             </a:r>
           </a:p>
         </p:txBody>
@@ -3184,8 +3184,8 @@
         </p:blipFill>
         <p:spPr>
           <a:xfrm>
-            <a:off x="4133791" y="0"/>
-            <a:ext cx="3924112" cy="6858000"/>
+            <a:off x="4421559" y="137160"/>
+            <a:ext cx="3348576" cy="5852160"/>
           </a:xfrm>
           <a:prstGeom prst="rect">
             <a:avLst/>
@@ -3200,8 +3200,8 @@
         </p:nvSpPr>
         <p:spPr>
           <a:xfrm>
-            <a:off x="274320" y="6217920"/>
-            <a:ext cx="10972800" cy="457200"/>
+            <a:off x="365760" y="5989320"/>
+            <a:ext cx="11430000" cy="777240"/>
           </a:xfrm>
           <a:prstGeom prst="rect">
             <a:avLst/>
@@ -3209,13 +3209,13 @@
           <a:noFill/>
         </p:spPr>
         <p:txBody>
-          <a:bodyPr wrap="none">
+          <a:bodyPr wrap="square">
             <a:spAutoFit/>
           </a:bodyPr>
           <a:lstStyle/>
           <a:p>
             <a:pPr>
-              <a:defRPr sz="1400">
+              <a:defRPr sz="1500">
                 <a:solidFill>
                   <a:srgbClr val="888888"/>
                 </a:solidFill>
@@ -3223,7 +3223,23 @@
               </a:defRPr>
             </a:pPr>
             <a:r>
-              <a:t>After — 3% slop</a:t>
+              <a:t>Creative Experiments — after · black-box gallery · merged into original</a:t>
+            </a:r>
+          </a:p>
+          <a:p>
+            <a:pPr>
+              <a:defRPr sz="1200">
+                <a:latin typeface="Arial"/>
+              </a:defRPr>
+            </a:pPr>
+            <a:r>
+              <a:rPr>
+                <a:solidFill>
+                  <a:srgbClr val="2563EB"/>
+                </a:solidFill>
+                <a:hlinkClick r:id="rId3"/>
+              </a:rPr>
+              <a:t>https://builtbysai.com/creative-experiments/</a:t>
             </a:r>
           </a:p>
         </p:txBody>
@@ -3262,8 +3278,8 @@
         </p:blipFill>
         <p:spPr>
           <a:xfrm>
-            <a:off x="5650819" y="0"/>
-            <a:ext cx="890056" cy="6858000"/>
+            <a:off x="5716090" y="137160"/>
+            <a:ext cx="759514" cy="5852160"/>
           </a:xfrm>
           <a:prstGeom prst="rect">
             <a:avLst/>
@@ -3278,8 +3294,8 @@
         </p:nvSpPr>
         <p:spPr>
           <a:xfrm>
-            <a:off x="274320" y="6217920"/>
-            <a:ext cx="10972800" cy="457200"/>
+            <a:off x="365760" y="5989320"/>
+            <a:ext cx="11430000" cy="777240"/>
           </a:xfrm>
           <a:prstGeom prst="rect">
             <a:avLst/>
@@ -3287,13 +3303,13 @@
           <a:noFill/>
         </p:spPr>
         <p:txBody>
-          <a:bodyPr wrap="none">
+          <a:bodyPr wrap="square">
             <a:spAutoFit/>
           </a:bodyPr>
           <a:lstStyle/>
           <a:p>
             <a:pPr>
-              <a:defRPr sz="1400">
+              <a:defRPr sz="1500">
                 <a:solidFill>
                   <a:srgbClr val="888888"/>
                 </a:solidFill>
@@ -3301,7 +3317,23 @@
               </a:defRPr>
             </a:pPr>
             <a:r>
-              <a:t>After — mobile</a:t>
+              <a:t>Creative Experiments — after · mobile</a:t>
+            </a:r>
+          </a:p>
+          <a:p>
+            <a:pPr>
+              <a:defRPr sz="1200">
+                <a:latin typeface="Arial"/>
+              </a:defRPr>
+            </a:pPr>
+            <a:r>
+              <a:rPr>
+                <a:solidFill>
+                  <a:srgbClr val="2563EB"/>
+                </a:solidFill>
+                <a:hlinkClick r:id="rId3"/>
+              </a:rPr>
+              <a:t>https://builtbysai.com/creative-experiments/</a:t>
             </a:r>
           </a:p>
         </p:txBody>

</xml_diff>